<commit_message>
George Brazil proposal: CFO-gone, on-site onboarding, offer more time
- Removed language implying the CFO is still available (he is gone):
  renamed the phase to Onboarding, timeline label to on-site onboarding &
  knowledge capture, and the 'what we ask' item to a named internal owner
- Added the on-site commitment to counter the not-on-location concern:
  Scottsdale-based with on-site time in Phoenix for onboarding and training
  Ian (slide 4 and the onboarding phase)
- Next steps now offers as much additional consultation time as they need,
  at no charge

Co-Authored-By: Claude Opus 4.8 <noreply@anthropic.com>
Claude-Session: https://claude.ai/code/session_01RfN2m1kgBo1xCWLXRNw2zV
</commit_message>
<xml_diff>
--- a/Onyx_GeorgeBrazil_Proposal.pptx
+++ b/Onyx_GeorgeBrazil_Proposal.pptx
@@ -8201,7 +8201,7 @@
                 <a:ea typeface="Calibri"/>
                 <a:cs typeface="Calibri"/>
               </a:rPr>
-              <a:t>A named internal owner, with the outgoing CFO available during the handover</a:t>
+              <a:t>A named internal owner for the engagement</a:t>
             </a:r>
           </a:p>
         </p:txBody>
@@ -8783,7 +8783,7 @@
                 <a:ea typeface="Calibri"/>
                 <a:cs typeface="Calibri"/>
               </a:rPr>
-              <a:t>Share this proposal with Marc, Shawn and Josh. We are glad to join or answer questions beforehand.</a:t>
+              <a:t>Share this proposal with Marc, Shawn and Josh. We are glad to join your review, or give you and the team as much additional time as you need, at no charge.</a:t>
             </a:r>
           </a:p>
         </p:txBody>
@@ -12887,7 +12887,7 @@
                 <a:ea typeface="Calibri"/>
                 <a:cs typeface="Calibri"/>
               </a:rPr>
-              <a:t>Engagement leadership, the controller and CFO roles, management and bank reporting, and every judgment call. Your day-to-day contacts sit here.</a:t>
+              <a:t>Engagement leadership, the controller and CFO roles, and every judgment call. Scottsdale-based, and on-site in Phoenix for onboarding and training your team.</a:t>
             </a:r>
           </a:p>
         </p:txBody>
@@ -16136,7 +16136,7 @@
                 <a:ea typeface="Cambria"/>
                 <a:cs typeface="Cambria"/>
               </a:rPr>
-              <a:t>HANDOVER</a:t>
+              <a:t>ONBOARDING</a:t>
             </a:r>
           </a:p>
         </p:txBody>
@@ -16214,7 +16214,7 @@
                 <a:ea typeface="Calibri"/>
                 <a:cs typeface="Calibri"/>
               </a:rPr>
-              <a:t>Capture what the CFO knew before the trail goes cold</a:t>
+              <a:t>On-site in Phoenix to onboard and begin training Ian</a:t>
             </a:r>
           </a:p>
           <a:p>
@@ -16234,7 +16234,7 @@
                 <a:ea typeface="Calibri"/>
                 <a:cs typeface="Calibri"/>
               </a:rPr>
-              <a:t>Document the close, bank-reporting and systems processes</a:t>
+              <a:t>Capture what the CFO knew, before the trail goes cold</a:t>
             </a:r>
           </a:p>
           <a:p>
@@ -16254,7 +16254,7 @@
                 <a:ea typeface="Calibri"/>
                 <a:cs typeface="Calibri"/>
               </a:rPr>
-              <a:t>Review access, Sage Intacct and the chart of accounts</a:t>
+              <a:t>Document the close, bank-reporting and systems processes</a:t>
             </a:r>
           </a:p>
           <a:p>
@@ -16274,7 +16274,7 @@
                 <a:ea typeface="Calibri"/>
                 <a:cs typeface="Calibri"/>
               </a:rPr>
-              <a:t>Support the 401(k) audit and the ready tax-return hand-off</a:t>
+              <a:t>Review access and Sage Intacct, and support the 401(k) audit</a:t>
             </a:r>
           </a:p>
         </p:txBody>
@@ -18517,7 +18517,7 @@
                 <a:ea typeface="Calibri"/>
                 <a:cs typeface="Calibri"/>
               </a:rPr>
-              <a:t>Knowledge transfer &amp; CFO handover</a:t>
+              <a:t>On-site onboarding &amp; knowledge capture</a:t>
             </a:r>
           </a:p>
         </p:txBody>

</xml_diff>

<commit_message>
George Brazil proposal: remove the complimentary quarterly standing offer
Co-Authored-By: Claude Opus 4.8 <noreply@anthropic.com>
Claude-Session: https://claude.ai/code/session_01RfN2m1kgBo1xCWLXRNw2zV
</commit_message>
<xml_diff>
--- a/Onyx_GeorgeBrazil_Proposal.pptx
+++ b/Onyx_GeorgeBrazil_Proposal.pptx
@@ -9410,80 +9410,6 @@
           <a:bodyPr rtlCol="0" anchor="ctr"/>
           <a:lstStyle/>
           <a:p/>
-        </p:txBody>
-      </p:sp>
-      <p:sp>
-        <p:nvSpPr>
-          <p:cNvPr id="24" name="TextBox 23"/>
-          <p:cNvSpPr txBox="1"/>
-          <p:nvPr/>
-        </p:nvSpPr>
-        <p:spPr>
-          <a:xfrm>
-            <a:off x="841247" y="4626864"/>
-            <a:ext cx="10506456" cy="237744"/>
-          </a:xfrm>
-          <a:prstGeom prst="rect">
-            <a:avLst/>
-          </a:prstGeom>
-          <a:noFill/>
-        </p:spPr>
-        <p:txBody>
-          <a:bodyPr wrap="square" lIns="0" tIns="0" rIns="0" bIns="0" anchor="t"/>
-          <a:lstStyle/>
-          <a:p>
-            <a:pPr algn="l" marL="0" indent="0">
-              <a:buNone/>
-            </a:pPr>
-            <a:r>
-              <a:rPr sz="1000" b="1" i="0">
-                <a:solidFill>
-                  <a:srgbClr val="B08D57"/>
-                </a:solidFill>
-                <a:latin typeface="Calibri"/>
-                <a:ea typeface="Calibri"/>
-                <a:cs typeface="Calibri"/>
-              </a:rPr>
-              <a:t>STANDING OFFER</a:t>
-            </a:r>
-          </a:p>
-        </p:txBody>
-      </p:sp>
-      <p:sp>
-        <p:nvSpPr>
-          <p:cNvPr id="25" name="TextBox 24"/>
-          <p:cNvSpPr txBox="1"/>
-          <p:nvPr/>
-        </p:nvSpPr>
-        <p:spPr>
-          <a:xfrm>
-            <a:off x="841247" y="4864608"/>
-            <a:ext cx="10506456" cy="292608"/>
-          </a:xfrm>
-          <a:prstGeom prst="rect">
-            <a:avLst/>
-          </a:prstGeom>
-          <a:noFill/>
-        </p:spPr>
-        <p:txBody>
-          <a:bodyPr wrap="square" lIns="0" tIns="0" rIns="0" bIns="0" anchor="t"/>
-          <a:lstStyle/>
-          <a:p>
-            <a:pPr algn="l" marL="0" indent="0">
-              <a:buNone/>
-            </a:pPr>
-            <a:r>
-              <a:rPr sz="1100" b="0" i="0">
-                <a:solidFill>
-                  <a:srgbClr val="D6D6D6"/>
-                </a:solidFill>
-                <a:latin typeface="Calibri"/>
-                <a:ea typeface="Calibri"/>
-                <a:cs typeface="Calibri"/>
-              </a:rPr>
-              <a:t>A complimentary accounting and treasury review each quarter with you and your executive board, for as long as we work together.</a:t>
-            </a:r>
-          </a:p>
         </p:txBody>
       </p:sp>
       <p:cxnSp>

</xml_diff>

<commit_message>
George Brazil: clean logos, name Jessica as controller, retainer to first invoice
Proposal deck: replaced the low-resolution logos with the full George Brazil
logo Steven supplied and the high-resolution ONYX wordmark from the letter
template (white version on the dark cover and closing slides). Jessica
Bumphus is named as the ONYX controller on the engagement team slide. The
retainer is now described as applied to the first invoice.

Templates (HOURLY and FIXED): the Retainer paragraph now applies the
retainer to ONYX's first invoice instead of the final invoice, with any
unapplied balance carried forward and refunded if unused. Recorded in
REWRITE-WALKTHROUGH.md and as a standing rule in CLAUDE.md.

Co-Authored-By: Claude Fable 5.1 <noreply@anthropic.com>
Claude-Session: https://claude.ai/code/session_01UFyPstJ3vPVTCKGNZ5pVUz
</commit_message>
<xml_diff>
--- a/Onyx_GeorgeBrazil_Proposal.pptx
+++ b/Onyx_GeorgeBrazil_Proposal.pptx
@@ -120,43 +120,43 @@
   <p:extLst>
     <p:ext uri="{521415D9-36F7-43E2-AB2F-B90AF26B5E84}">
       <p14:sectionLst xmlns:p14="http://schemas.microsoft.com/office/powerpoint/2010/main">
-        <p14:section name="Introduction" id="{3aaaa6bc-2390-4b09-ea5d-ddf692e8baeb}">
+        <p14:section name="Introduction" id="{b1d96e7a-d300-bde4-a091-80041a032d12}">
           <p14:sldIdLst>
             <p14:sldId id="256"/>
             <p14:sldId id="257"/>
             <p14:sldId id="258"/>
           </p14:sldIdLst>
         </p14:section>
-        <p14:section name="01 Who we are" id="{53299a3a-e365-d82f-93e2-59e919bda2d8}">
+        <p14:section name="01 Who we are" id="{5b6fda35-cd83-edd0-15f7-32d0b39d9957}">
           <p14:sldIdLst>
             <p14:sldId id="259"/>
             <p14:sldId id="260"/>
           </p14:sldIdLst>
         </p14:section>
-        <p14:section name="02 What we can help with" id="{b894b7c0-f082-40b4-8167-41a7a788ca98}">
+        <p14:section name="02 What we can help with" id="{1ba2d6a9-7847-603d-3342-13f58974195b}">
           <p14:sldIdLst>
             <p14:sldId id="261"/>
             <p14:sldId id="262"/>
             <p14:sldId id="263"/>
           </p14:sldIdLst>
         </p14:section>
-        <p14:section name="03 Engagement timeline" id="{a56f2e52-395e-74ad-bb17-d0a32f0cb33c}">
+        <p14:section name="03 Engagement timeline" id="{3f10b918-da9e-01c8-cf96-b789058d955d}">
           <p14:sldIdLst>
             <p14:sldId id="264"/>
           </p14:sldIdLst>
         </p14:section>
-        <p14:section name="04 30/60/90-day plan" id="{5eb1175b-7f51-b5fd-d86b-5c9c9fd96af0}">
+        <p14:section name="04 30/60/90-day plan" id="{f849e595-5ada-664d-0b5b-74e1cc260955}">
           <p14:sldIdLst>
             <p14:sldId id="265"/>
             <p14:sldId id="266"/>
           </p14:sldIdLst>
         </p14:section>
-        <p14:section name="05 Proposed fees" id="{647d2297-cffa-1abe-a5cd-27ff0c9c10eb}">
+        <p14:section name="05 Proposed fees" id="{25d3ef18-67c8-28e9-05a1-d5180be44661}">
           <p14:sldIdLst>
             <p14:sldId id="267"/>
           </p14:sldIdLst>
         </p14:section>
-        <p14:section name="06 Why ONYX and next steps" id="{23afce25-722e-4cad-06ff-37c1af78d06c}">
+        <p14:section name="06 Why ONYX and next steps" id="{a382a80e-98a7-b07c-2c3d-ad824c6add10}">
           <p14:sldIdLst>
             <p14:sldId id="268"/>
             <p14:sldId id="269"/>
@@ -1875,7 +1875,7 @@
         <p:spPr>
           <a:xfrm>
             <a:off x="10500055" y="301752"/>
-            <a:ext cx="1143000" cy="536753"/>
+            <a:ext cx="1143000" cy="537667"/>
           </a:xfrm>
           <a:prstGeom prst="rect">
             <a:avLst/>
@@ -2090,7 +2090,7 @@
         <p:spPr>
           <a:xfrm>
             <a:off x="548640" y="457200"/>
-            <a:ext cx="1463040" cy="686714"/>
+            <a:ext cx="1463040" cy="687629"/>
           </a:xfrm>
           <a:prstGeom prst="rect">
             <a:avLst/>
@@ -2464,7 +2464,7 @@
         <p:spPr>
           <a:xfrm>
             <a:off x="548640" y="548640"/>
-            <a:ext cx="1828800" cy="858622"/>
+            <a:ext cx="1828800" cy="859536"/>
           </a:xfrm>
           <a:prstGeom prst="rect">
             <a:avLst/>
@@ -7358,7 +7358,7 @@
                   <a:schemeClr val="tx1"/>
                 </a:solidFill>
               </a:rPr>
-              <a:t>Retainer of $3,000 before services begin, applied to the final invoice</a:t>
+              <a:t>Retainer of $3,000 before services begin, applied to the first invoice</a:t>
             </a:r>
             <a:endParaRPr lang="en-US" sz="1150" dirty="0"/>
           </a:p>
@@ -11708,7 +11708,7 @@
                   <a:schemeClr val="accent3"/>
                 </a:solidFill>
               </a:rPr>
-              <a:t>The principal leads the engagement and stays on it. The controller and staff roles are filled from our team at kickoff, and the mix is adjusted with you as the work settles.</a:t>
+              <a:t>The principal leads the engagement and stays on it. Jessica Bumphus, who joined us at the October 2 meeting, leads the controller work. Staff support is assigned at kickoff, and the mix is adjusted with you as the work settles.</a:t>
             </a:r>
             <a:endParaRPr lang="en-US" sz="1250" dirty="0"/>
           </a:p>
@@ -12600,7 +12600,7 @@
                           <a:ea typeface="Calibri" pitchFamily="34" charset="-122"/>
                           <a:cs typeface="Calibri" pitchFamily="34" charset="-120"/>
                         </a:rPr>
-                        <a:t>ONYX Controller</a:t>
+                        <a:t>Jessica Bumphus</a:t>
                       </a:r>
                       <a:endParaRPr lang="en-US" sz="1100" dirty="0">
                         <a:latin typeface="Calibri" charset="0"/>
@@ -12621,7 +12621,7 @@
                           <a:ea typeface="Calibri" pitchFamily="34" charset="-122"/>
                           <a:cs typeface="Calibri" pitchFamily="34" charset="-120"/>
                         </a:rPr>
-                        <a:t>Assigned at kickoff</a:t>
+                        <a:t>Controller, jessica@onyxcfo.com</a:t>
                       </a:r>
                       <a:endParaRPr lang="en-US" sz="1100" dirty="0">
                         <a:latin typeface="Calibri" charset="0"/>
@@ -12686,7 +12686,7 @@
                           <a:ea typeface="Calibri" pitchFamily="34" charset="-122"/>
                           <a:cs typeface="Calibri" pitchFamily="34" charset="-120"/>
                         </a:rPr>
-                        <a:t>Controller</a:t>
+                        <a:t>ONYX controller</a:t>
                       </a:r>
                       <a:endParaRPr lang="en-US" sz="1100" dirty="0">
                         <a:latin typeface="Calibri" charset="0"/>

</xml_diff>

<commit_message>
George Brazil: date proposal October 5 to match the letter; drop email from team table
Co-Authored-By: Claude Fable 5.1 <noreply@anthropic.com>
Claude-Session: https://claude.ai/code/session_01UFyPstJ3vPVTCKGNZ5pVUz
</commit_message>
<xml_diff>
--- a/Onyx_GeorgeBrazil_Proposal.pptx
+++ b/Onyx_GeorgeBrazil_Proposal.pptx
@@ -120,43 +120,43 @@
   <p:extLst>
     <p:ext uri="{521415D9-36F7-43E2-AB2F-B90AF26B5E84}">
       <p14:sectionLst xmlns:p14="http://schemas.microsoft.com/office/powerpoint/2010/main">
-        <p14:section name="Introduction" id="{b1d96e7a-d300-bde4-a091-80041a032d12}">
+        <p14:section name="Introduction" id="{8fd9e79a-e356-4544-6a09-9a1d45d72eae}">
           <p14:sldIdLst>
             <p14:sldId id="256"/>
             <p14:sldId id="257"/>
             <p14:sldId id="258"/>
           </p14:sldIdLst>
         </p14:section>
-        <p14:section name="01 Who we are" id="{5b6fda35-cd83-edd0-15f7-32d0b39d9957}">
+        <p14:section name="01 Who we are" id="{6920c485-f38d-0467-708e-bf131f7eedbf}">
           <p14:sldIdLst>
             <p14:sldId id="259"/>
             <p14:sldId id="260"/>
           </p14:sldIdLst>
         </p14:section>
-        <p14:section name="02 What we can help with" id="{1ba2d6a9-7847-603d-3342-13f58974195b}">
+        <p14:section name="02 What we can help with" id="{d865d581-ab5b-50e4-5ce6-5c1110189744}">
           <p14:sldIdLst>
             <p14:sldId id="261"/>
             <p14:sldId id="262"/>
             <p14:sldId id="263"/>
           </p14:sldIdLst>
         </p14:section>
-        <p14:section name="03 Engagement timeline" id="{3f10b918-da9e-01c8-cf96-b789058d955d}">
+        <p14:section name="03 Engagement timeline" id="{be9016a4-bced-42ae-d5bd-4f440ffb9306}">
           <p14:sldIdLst>
             <p14:sldId id="264"/>
           </p14:sldIdLst>
         </p14:section>
-        <p14:section name="04 30/60/90-day plan" id="{f849e595-5ada-664d-0b5b-74e1cc260955}">
+        <p14:section name="04 30/60/90-day plan" id="{d18e2fdc-9b0b-f83d-9c01-56e6f221050f}">
           <p14:sldIdLst>
             <p14:sldId id="265"/>
             <p14:sldId id="266"/>
           </p14:sldIdLst>
         </p14:section>
-        <p14:section name="05 Proposed fees" id="{25d3ef18-67c8-28e9-05a1-d5180be44661}">
+        <p14:section name="05 Proposed fees" id="{8a093d5d-e9fb-cdce-3c1b-581f527438cf}">
           <p14:sldIdLst>
             <p14:sldId id="267"/>
           </p14:sldIdLst>
         </p14:section>
-        <p14:section name="06 Why ONYX and next steps" id="{a382a80e-98a7-b07c-2c3d-ad824c6add10}">
+        <p14:section name="06 Why ONYX and next steps" id="{7ce09cf9-53e3-4c8f-df64-ad829310b33f}">
           <p14:sldIdLst>
             <p14:sldId id="268"/>
             <p14:sldId id="269"/>
@@ -566,7 +566,7 @@
           <a:p>
             <a:r>
               <a:rPr lang="en-US" dirty="0"/>
-              <a:t>Cover. Proposal accompanies the engagement letter sent October 5, 2026.</a:t>
+              <a:t>Cover. Proposal accompanies the engagement letter dated October 5, 2026.</a:t>
             </a:r>
             <a:endParaRPr lang="en-US" dirty="0"/>
           </a:p>
@@ -2543,7 +2543,7 @@
                   <a:schemeClr val="bg1"/>
                 </a:solidFill>
               </a:rPr>
-              <a:t>October 7, 2026</a:t>
+              <a:t>October 5, 2026</a:t>
             </a:r>
             <a:endParaRPr lang="en-US" sz="1200" dirty="0"/>
           </a:p>
@@ -9352,7 +9352,7 @@
                   <a:schemeClr val="accent3"/>
                 </a:solidFill>
               </a:rPr>
-              <a:t>October 7, 2026</a:t>
+              <a:t>October 5, 2026</a:t>
             </a:r>
             <a:endParaRPr lang="en-US" sz="1200" dirty="0"/>
           </a:p>
@@ -9491,7 +9491,7 @@
                   <a:schemeClr val="tx1"/>
                 </a:solidFill>
               </a:rPr>
-              <a:t>Thank you for the time you, Shawne, Josh and Ian gave us at your office on October 2. This proposal accompanies the engagement letter we sent on October 5 and describes how Onyx Accounting Group would support George Brazil following your CFO's departure.</a:t>
+              <a:t>Thank you for the time you, Shawne, Josh and Ian gave us at your office on October 2. This proposal accompanies the enclosed engagement letter and describes how Onyx Accounting Group would support George Brazil following your CFO's departure.</a:t>
             </a:r>
             <a:endParaRPr lang="en-US" sz="1250" dirty="0"/>
           </a:p>
@@ -12621,7 +12621,7 @@
                           <a:ea typeface="Calibri" pitchFamily="34" charset="-122"/>
                           <a:cs typeface="Calibri" pitchFamily="34" charset="-120"/>
                         </a:rPr>
-                        <a:t>Controller, jessica@onyxcfo.com</a:t>
+                        <a:t>Controller</a:t>
                       </a:r>
                       <a:endParaRPr lang="en-US" sz="1100" dirty="0">
                         <a:latin typeface="Calibri" charset="0"/>

</xml_diff>

<commit_message>
George Brazil proposal: tighten Next-steps panel (Sign->Grant), revert left-panel nudge
The earlier spacing fix targeted the wrong panel. Reverted the left
'why ONYX' nudge and tightened the right 'Next steps' panel between
Sign (2) and Grant access (3), compensating for Sign's shorter two-line
description.

Co-Authored-By: Claude Opus 4.8 <noreply@anthropic.com>
Claude-Session: https://claude.ai/code/session_01RfN2m1kgBo1xCWLXRNw2zV
</commit_message>
<xml_diff>
--- a/Onyx_GeorgeBrazil_Proposal.pptx
+++ b/Onyx_GeorgeBrazil_Proposal.pptx
@@ -7972,7 +7972,7 @@
         </p:nvSpPr>
         <p:spPr>
           <a:xfrm>
-            <a:off x="548640" y="3794760"/>
+            <a:off x="548640" y="3904488"/>
             <a:ext cx="384048" cy="384048"/>
           </a:xfrm>
           <a:prstGeom prst="ellipse">
@@ -8004,7 +8004,7 @@
         </p:nvSpPr>
         <p:spPr>
           <a:xfrm>
-            <a:off x="548640" y="3794760"/>
+            <a:off x="548640" y="3904488"/>
             <a:ext cx="384048" cy="384048"/>
           </a:xfrm>
           <a:prstGeom prst="rect">
@@ -8040,7 +8040,7 @@
         </p:nvSpPr>
         <p:spPr>
           <a:xfrm>
-            <a:off x="1097280" y="3767328"/>
+            <a:off x="1097280" y="3877056"/>
             <a:ext cx="5212080" cy="274320"/>
           </a:xfrm>
           <a:prstGeom prst="rect">
@@ -8076,7 +8076,7 @@
         </p:nvSpPr>
         <p:spPr>
           <a:xfrm>
-            <a:off x="1097280" y="4041648"/>
+            <a:off x="1097280" y="4151376"/>
             <a:ext cx="5212080" cy="658368"/>
           </a:xfrm>
           <a:prstGeom prst="rect">
@@ -8112,7 +8112,7 @@
         </p:nvSpPr>
         <p:spPr>
           <a:xfrm>
-            <a:off x="548640" y="4727448"/>
+            <a:off x="548640" y="4837176"/>
             <a:ext cx="384048" cy="384048"/>
           </a:xfrm>
           <a:prstGeom prst="ellipse">
@@ -8144,7 +8144,7 @@
         </p:nvSpPr>
         <p:spPr>
           <a:xfrm>
-            <a:off x="548640" y="4727448"/>
+            <a:off x="548640" y="4837176"/>
             <a:ext cx="384048" cy="384048"/>
           </a:xfrm>
           <a:prstGeom prst="rect">
@@ -8180,7 +8180,7 @@
         </p:nvSpPr>
         <p:spPr>
           <a:xfrm>
-            <a:off x="1097280" y="4700016"/>
+            <a:off x="1097280" y="4809744"/>
             <a:ext cx="5212080" cy="274320"/>
           </a:xfrm>
           <a:prstGeom prst="rect">
@@ -8216,7 +8216,7 @@
         </p:nvSpPr>
         <p:spPr>
           <a:xfrm>
-            <a:off x="1097280" y="4974336"/>
+            <a:off x="1097280" y="5084064"/>
             <a:ext cx="5212080" cy="658368"/>
           </a:xfrm>
           <a:prstGeom prst="rect">
@@ -8545,7 +8545,7 @@
         </p:nvSpPr>
         <p:spPr>
           <a:xfrm>
-            <a:off x="7086600" y="4160520"/>
+            <a:off x="7086600" y="3977640"/>
             <a:ext cx="365760" cy="365760"/>
           </a:xfrm>
           <a:prstGeom prst="rect">
@@ -8584,7 +8584,7 @@
         </p:nvSpPr>
         <p:spPr>
           <a:xfrm>
-            <a:off x="7543800" y="4160520"/>
+            <a:off x="7543800" y="3977640"/>
             <a:ext cx="3779215" cy="274320"/>
           </a:xfrm>
           <a:prstGeom prst="rect">
@@ -8620,7 +8620,7 @@
         </p:nvSpPr>
         <p:spPr>
           <a:xfrm>
-            <a:off x="7543800" y="4434840"/>
+            <a:off x="7543800" y="4251960"/>
             <a:ext cx="3779215" cy="640080"/>
           </a:xfrm>
           <a:prstGeom prst="rect">
@@ -8656,7 +8656,7 @@
         </p:nvSpPr>
         <p:spPr>
           <a:xfrm>
-            <a:off x="7086600" y="5120640"/>
+            <a:off x="7086600" y="4937760"/>
             <a:ext cx="365760" cy="365760"/>
           </a:xfrm>
           <a:prstGeom prst="rect">
@@ -8695,7 +8695,7 @@
         </p:nvSpPr>
         <p:spPr>
           <a:xfrm>
-            <a:off x="7543800" y="5120640"/>
+            <a:off x="7543800" y="4937760"/>
             <a:ext cx="3779215" cy="274320"/>
           </a:xfrm>
           <a:prstGeom prst="rect">
@@ -8731,7 +8731,7 @@
         </p:nvSpPr>
         <p:spPr>
           <a:xfrm>
-            <a:off x="7543800" y="5394960"/>
+            <a:off x="7543800" y="5212080"/>
             <a:ext cx="3779215" cy="640080"/>
           </a:xfrm>
           <a:prstGeom prst="rect">

</xml_diff>

<commit_message>
George Brazil proposal: tighten slide 4 Supporting staff -> Perform and review gap
Shortening the supporting-staff line left a gap before Perform and review;
pulled Perform and review and One file up to close it.

Co-Authored-By: Claude Opus 4.8 <noreply@anthropic.com>
Claude-Session: https://claude.ai/code/session_01RfN2m1kgBo1xCWLXRNw2zV
</commit_message>
<xml_diff>
--- a/Onyx_GeorgeBrazil_Proposal.pptx
+++ b/Onyx_GeorgeBrazil_Proposal.pptx
@@ -11432,7 +11432,7 @@
         </p:nvSpPr>
         <p:spPr>
           <a:xfrm>
-            <a:off x="6858000" y="4050792"/>
+            <a:off x="6858000" y="3867912"/>
             <a:ext cx="4510735" cy="274320"/>
           </a:xfrm>
           <a:prstGeom prst="rect">
@@ -11468,7 +11468,7 @@
         </p:nvSpPr>
         <p:spPr>
           <a:xfrm>
-            <a:off x="6858000" y="4325112"/>
+            <a:off x="6858000" y="4142232"/>
             <a:ext cx="4510735" cy="658368"/>
           </a:xfrm>
           <a:prstGeom prst="rect">
@@ -11504,7 +11504,7 @@
         </p:nvSpPr>
         <p:spPr>
           <a:xfrm>
-            <a:off x="6858000" y="5010912"/>
+            <a:off x="6858000" y="4828032"/>
             <a:ext cx="4510735" cy="274320"/>
           </a:xfrm>
           <a:prstGeom prst="rect">
@@ -11540,7 +11540,7 @@
         </p:nvSpPr>
         <p:spPr>
           <a:xfrm>
-            <a:off x="6858000" y="5285232"/>
+            <a:off x="6858000" y="5102352"/>
             <a:ext cx="4510735" cy="658368"/>
           </a:xfrm>
           <a:prstGeom prst="rect">

</xml_diff>

<commit_message>
George Brazil proposal: tighten slide 4 left column (Industry -> Ownership)
Pulled Ownership structures up so the gap after the shorter Industry
experience description matches the rest of the column.

Co-Authored-By: Claude Opus 4.8 <noreply@anthropic.com>
Claude-Session: https://claude.ai/code/session_01RfN2m1kgBo1xCWLXRNw2zV
</commit_message>
<xml_diff>
--- a/Onyx_GeorgeBrazil_Proposal.pptx
+++ b/Onyx_GeorgeBrazil_Proposal.pptx
@@ -11074,7 +11074,7 @@
         </p:nvSpPr>
         <p:spPr>
           <a:xfrm>
-            <a:off x="548640" y="5212080"/>
+            <a:off x="548640" y="5065776"/>
             <a:ext cx="384048" cy="384048"/>
           </a:xfrm>
           <a:prstGeom prst="ellipse">
@@ -11106,7 +11106,7 @@
         </p:nvSpPr>
         <p:spPr>
           <a:xfrm>
-            <a:off x="548640" y="5212080"/>
+            <a:off x="548640" y="5065776"/>
             <a:ext cx="384048" cy="384048"/>
           </a:xfrm>
           <a:prstGeom prst="rect">
@@ -11142,7 +11142,7 @@
         </p:nvSpPr>
         <p:spPr>
           <a:xfrm>
-            <a:off x="1097280" y="5166360"/>
+            <a:off x="1097280" y="5020056"/>
             <a:ext cx="4937760" cy="274320"/>
           </a:xfrm>
           <a:prstGeom prst="rect">
@@ -11181,7 +11181,7 @@
         </p:nvSpPr>
         <p:spPr>
           <a:xfrm>
-            <a:off x="1097280" y="5440680"/>
+            <a:off x="1097280" y="5294376"/>
             <a:ext cx="4937760" cy="640080"/>
           </a:xfrm>
           <a:prstGeom prst="rect">

</xml_diff>